<commit_message>
Add multi-material visualization poster assets
</commit_message>
<xml_diff>
--- a/xrayrecon_update_2026-07-02_academic.pptx
+++ b/xrayrecon_update_2026-07-02_academic.pptx
@@ -5,7 +5,7 @@
     <p:sldMasterId id="2147483648" r:id="rId1"/>
   </p:sldMasterIdLst>
   <p:notesMasterIdLst>
-    <p:notesMasterId r:id="rId13"/>
+    <p:notesMasterId r:id="rId12"/>
   </p:notesMasterIdLst>
   <p:sldIdLst>
     <p:sldId id="256" r:id="rId2"/>
@@ -15,10 +15,9 @@
     <p:sldId id="260" r:id="rId6"/>
     <p:sldId id="261" r:id="rId7"/>
     <p:sldId id="262" r:id="rId8"/>
-    <p:sldId id="263" r:id="rId9"/>
-    <p:sldId id="264" r:id="rId10"/>
-    <p:sldId id="265" r:id="rId11"/>
-    <p:sldId id="266" r:id="rId12"/>
+    <p:sldId id="264" r:id="rId9"/>
+    <p:sldId id="265" r:id="rId10"/>
+    <p:sldId id="266" r:id="rId11"/>
   </p:sldIdLst>
   <p:sldSz cx="12192000" cy="6858000"/>
   <p:notesSz cx="6858000" cy="9144000"/>
@@ -3999,426 +3998,6 @@
     <p:bg>
       <p:bgPr>
         <a:solidFill>
-          <a:srgbClr val="FFFFFF"/>
-        </a:solidFill>
-        <a:effectLst/>
-      </p:bgPr>
-    </p:bg>
-    <p:spTree>
-      <p:nvGrpSpPr>
-        <p:cNvPr id="1" name=""/>
-        <p:cNvGrpSpPr/>
-        <p:nvPr/>
-      </p:nvGrpSpPr>
-      <p:grpSpPr>
-        <a:xfrm>
-          <a:off x="0" y="0"/>
-          <a:ext cx="0" cy="0"/>
-          <a:chOff x="0" y="0"/>
-          <a:chExt cx="0" cy="0"/>
-        </a:xfrm>
-      </p:grpSpPr>
-      <p:sp>
-        <p:nvSpPr>
-          <p:cNvPr id="2" name="TextBox 1"/>
-          <p:cNvSpPr txBox="1"/>
-          <p:nvPr/>
-        </p:nvSpPr>
-        <p:spPr>
-          <a:xfrm>
-            <a:off x="457200" y="274320"/>
-            <a:ext cx="11277295" cy="868680"/>
-          </a:xfrm>
-          <a:prstGeom prst="rect">
-            <a:avLst/>
-          </a:prstGeom>
-          <a:noFill/>
-        </p:spPr>
-        <p:txBody>
-          <a:bodyPr wrap="square" lIns="0" tIns="0" rIns="0" bIns="0" anchor="t">
-            <a:spAutoFit/>
-          </a:bodyPr>
-          <a:lstStyle/>
-          <a:p>
-            <a:pPr algn="l">
-              <a:lnSpc>
-                <a:spcPct val="105000"/>
-              </a:lnSpc>
-            </a:pPr>
-            <a:r>
-              <a:rPr sz="2600" b="1" i="0">
-                <a:solidFill>
-                  <a:srgbClr val="1F4E79"/>
-                </a:solidFill>
-                <a:latin typeface="Arial"/>
-              </a:rPr>
-              <a:t>Z_eff noise limits classification accuracy, and no real matched dataset exists yet to validate end-to-end</a:t>
-            </a:r>
-          </a:p>
-        </p:txBody>
-      </p:sp>
-      <p:sp>
-        <p:nvSpPr>
-          <p:cNvPr id="3" name="Rectangle 2"/>
-          <p:cNvSpPr/>
-          <p:nvPr/>
-        </p:nvSpPr>
-        <p:spPr>
-          <a:xfrm>
-            <a:off x="457200" y="1097280"/>
-            <a:ext cx="11277295" cy="19050"/>
-          </a:xfrm>
-          <a:prstGeom prst="rect">
-            <a:avLst/>
-          </a:prstGeom>
-          <a:solidFill>
-            <a:srgbClr val="CCCCCC"/>
-          </a:solidFill>
-          <a:ln>
-            <a:noFill/>
-          </a:ln>
-          <a:effectLst/>
-        </p:spPr>
-        <p:style>
-          <a:lnRef idx="1">
-            <a:schemeClr val="accent1"/>
-          </a:lnRef>
-          <a:fillRef idx="3">
-            <a:schemeClr val="accent1"/>
-          </a:fillRef>
-          <a:effectRef idx="2">
-            <a:schemeClr val="accent1"/>
-          </a:effectRef>
-          <a:fontRef idx="minor">
-            <a:schemeClr val="lt1"/>
-          </a:fontRef>
-        </p:style>
-        <p:txBody>
-          <a:bodyPr rtlCol="0" anchor="ctr"/>
-          <a:lstStyle/>
-          <a:p>
-            <a:pPr algn="ctr"/>
-            <a:endParaRPr/>
-          </a:p>
-        </p:txBody>
-      </p:sp>
-      <p:sp>
-        <p:nvSpPr>
-          <p:cNvPr id="4" name="TextBox 3"/>
-          <p:cNvSpPr txBox="1"/>
-          <p:nvPr/>
-        </p:nvSpPr>
-        <p:spPr>
-          <a:xfrm>
-            <a:off x="457200" y="1234440"/>
-            <a:ext cx="5486400" cy="365760"/>
-          </a:xfrm>
-          <a:prstGeom prst="rect">
-            <a:avLst/>
-          </a:prstGeom>
-          <a:noFill/>
-        </p:spPr>
-        <p:txBody>
-          <a:bodyPr wrap="square" lIns="0" tIns="0" rIns="0" bIns="0" anchor="t">
-            <a:spAutoFit/>
-          </a:bodyPr>
-          <a:lstStyle/>
-          <a:p>
-            <a:pPr algn="l">
-              <a:lnSpc>
-                <a:spcPct val="100000"/>
-              </a:lnSpc>
-            </a:pPr>
-            <a:r>
-              <a:rPr sz="2200" b="1" i="0">
-                <a:solidFill>
-                  <a:srgbClr val="2E75B6"/>
-                </a:solidFill>
-                <a:latin typeface="Arial"/>
-              </a:rPr>
-              <a:t>Interpretation</a:t>
-            </a:r>
-          </a:p>
-        </p:txBody>
-      </p:sp>
-      <p:sp>
-        <p:nvSpPr>
-          <p:cNvPr id="5" name="TextBox 4"/>
-          <p:cNvSpPr txBox="1"/>
-          <p:nvPr/>
-        </p:nvSpPr>
-        <p:spPr>
-          <a:xfrm>
-            <a:off x="457200" y="1645920"/>
-            <a:ext cx="5486400" cy="2011680"/>
-          </a:xfrm>
-          <a:prstGeom prst="rect">
-            <a:avLst/>
-          </a:prstGeom>
-          <a:noFill/>
-        </p:spPr>
-        <p:txBody>
-          <a:bodyPr wrap="square">
-            <a:spAutoFit/>
-          </a:bodyPr>
-          <a:lstStyle/>
-          <a:p>
-            <a:pPr>
-              <a:lnSpc>
-                <a:spcPct val="105000"/>
-              </a:lnSpc>
-              <a:spcAft>
-                <a:spcPts val="1200"/>
-              </a:spcAft>
-            </a:pPr>
-            <a:r>
-              <a:rPr sz="1900">
-                <a:solidFill>
-                  <a:srgbClr val="2D2D2D"/>
-                </a:solidFill>
-                <a:latin typeface="Arial"/>
-              </a:rPr>
-              <a:t>•  Ground-truth classification: 100% correct (exact input, sanity check).</a:t>
-            </a:r>
-          </a:p>
-          <a:p>
-            <a:pPr>
-              <a:lnSpc>
-                <a:spcPct val="105000"/>
-              </a:lnSpc>
-              <a:spcAft>
-                <a:spcPts val="1200"/>
-              </a:spcAft>
-            </a:pPr>
-            <a:r>
-              <a:rPr sz="1900">
-                <a:solidFill>
-                  <a:srgbClr val="2D2D2D"/>
-                </a:solidFill>
-                <a:latin typeface="Arial"/>
-              </a:rPr>
-              <a:t>•  Recovered/noisy classification: 56% voxel agreement against ground truth.</a:t>
-            </a:r>
-          </a:p>
-          <a:p>
-            <a:pPr>
-              <a:lnSpc>
-                <a:spcPct val="105000"/>
-              </a:lnSpc>
-              <a:spcAft>
-                <a:spcPts val="1200"/>
-              </a:spcAft>
-            </a:pPr>
-            <a:r>
-              <a:rPr sz="1900" b="1">
-                <a:solidFill>
-                  <a:srgbClr val="2D2D2D"/>
-                </a:solidFill>
-                <a:latin typeface="Arial"/>
-              </a:rPr>
-              <a:t>•  Cause: </a:t>
-            </a:r>
-            <a:r>
-              <a:rPr sz="1900" b="0">
-                <a:solidFill>
-                  <a:srgbClr val="2D2D2D"/>
-                </a:solidFill>
-                <a:latin typeface="Arial"/>
-              </a:rPr>
-              <a:t>Z_eff's ratio-based recovery is inherently noisier than ρ_e, especially for low-Z materials like FR4.</a:t>
-            </a:r>
-          </a:p>
-        </p:txBody>
-      </p:sp>
-      <p:graphicFrame>
-        <p:nvGraphicFramePr>
-          <p:cNvPr id="6" name="Chart 5"/>
-          <p:cNvGraphicFramePr>
-            <a:graphicFrameLocks noGrp="1"/>
-          </p:cNvGraphicFramePr>
-          <p:nvPr/>
-        </p:nvGraphicFramePr>
-        <p:xfrm>
-          <a:off x="6309360" y="1371600"/>
-          <a:ext cx="5029200" cy="3108960"/>
-        </p:xfrm>
-        <a:graphic>
-          <a:graphicData uri="http://schemas.openxmlformats.org/drawingml/2006/chart">
-            <c:chart xmlns:c="http://schemas.openxmlformats.org/drawingml/2006/chart" xmlns:r="http://schemas.openxmlformats.org/officeDocument/2006/relationships" r:id="rId2"/>
-          </a:graphicData>
-        </a:graphic>
-      </p:graphicFrame>
-      <p:sp>
-        <p:nvSpPr>
-          <p:cNvPr id="7" name="TextBox 6"/>
-          <p:cNvSpPr txBox="1"/>
-          <p:nvPr/>
-        </p:nvSpPr>
-        <p:spPr>
-          <a:xfrm>
-            <a:off x="457200" y="4434840"/>
-            <a:ext cx="5486400" cy="365760"/>
-          </a:xfrm>
-          <a:prstGeom prst="rect">
-            <a:avLst/>
-          </a:prstGeom>
-          <a:noFill/>
-        </p:spPr>
-        <p:txBody>
-          <a:bodyPr wrap="square" lIns="0" tIns="0" rIns="0" bIns="0" anchor="t">
-            <a:spAutoFit/>
-          </a:bodyPr>
-          <a:lstStyle/>
-          <a:p>
-            <a:pPr algn="l">
-              <a:lnSpc>
-                <a:spcPct val="100000"/>
-              </a:lnSpc>
-            </a:pPr>
-            <a:r>
-              <a:rPr sz="2200" b="1" i="0">
-                <a:solidFill>
-                  <a:srgbClr val="2E75B6"/>
-                </a:solidFill>
-                <a:latin typeface="Arial"/>
-              </a:rPr>
-              <a:t>Main limitation</a:t>
-            </a:r>
-          </a:p>
-        </p:txBody>
-      </p:sp>
-      <p:sp>
-        <p:nvSpPr>
-          <p:cNvPr id="8" name="TextBox 7"/>
-          <p:cNvSpPr txBox="1"/>
-          <p:nvPr/>
-        </p:nvSpPr>
-        <p:spPr>
-          <a:xfrm>
-            <a:off x="457200" y="4846320"/>
-            <a:ext cx="11277295" cy="1463040"/>
-          </a:xfrm>
-          <a:prstGeom prst="rect">
-            <a:avLst/>
-          </a:prstGeom>
-          <a:noFill/>
-        </p:spPr>
-        <p:txBody>
-          <a:bodyPr wrap="square">
-            <a:spAutoFit/>
-          </a:bodyPr>
-          <a:lstStyle/>
-          <a:p>
-            <a:pPr>
-              <a:lnSpc>
-                <a:spcPct val="105000"/>
-              </a:lnSpc>
-              <a:spcAft>
-                <a:spcPts val="1200"/>
-              </a:spcAft>
-            </a:pPr>
-            <a:r>
-              <a:rPr sz="1900" b="1">
-                <a:solidFill>
-                  <a:srgbClr val="2D2D2D"/>
-                </a:solidFill>
-                <a:latin typeface="Arial"/>
-              </a:rPr>
-              <a:t>•  External validity: </a:t>
-            </a:r>
-            <a:r>
-              <a:rPr sz="1900" b="0">
-                <a:solidFill>
-                  <a:srgbClr val="2D2D2D"/>
-                </a:solidFill>
-                <a:latin typeface="Arial"/>
-              </a:rPr>
-              <a:t>the only real CT sample in the repo is a battery scan, not a PCB—end-to-end registration is validated only on synthetic data so far.</a:t>
-            </a:r>
-          </a:p>
-          <a:p>
-            <a:pPr>
-              <a:lnSpc>
-                <a:spcPct val="105000"/>
-              </a:lnSpc>
-              <a:spcAft>
-                <a:spcPts val="1200"/>
-              </a:spcAft>
-            </a:pPr>
-            <a:r>
-              <a:rPr sz="1900" b="1">
-                <a:solidFill>
-                  <a:srgbClr val="2D2D2D"/>
-                </a:solidFill>
-                <a:latin typeface="Arial"/>
-              </a:rPr>
-              <a:t>•  Next validation step: </a:t>
-            </a:r>
-            <a:r>
-              <a:rPr sz="1900" b="0">
-                <a:solidFill>
-                  <a:srgbClr val="2D2D2D"/>
-                </a:solidFill>
-                <a:latin typeface="Arial"/>
-              </a:rPr>
-              <a:t>acquire or locate a real CT scan with a matching known Gerber design.</a:t>
-            </a:r>
-          </a:p>
-        </p:txBody>
-      </p:sp>
-      <p:sp>
-        <p:nvSpPr>
-          <p:cNvPr id="9" name="TextBox 8"/>
-          <p:cNvSpPr txBox="1"/>
-          <p:nvPr/>
-        </p:nvSpPr>
-        <p:spPr>
-          <a:xfrm>
-            <a:off x="457200" y="6446520"/>
-            <a:ext cx="11277295" cy="320040"/>
-          </a:xfrm>
-          <a:prstGeom prst="rect">
-            <a:avLst/>
-          </a:prstGeom>
-          <a:noFill/>
-        </p:spPr>
-        <p:txBody>
-          <a:bodyPr wrap="square" lIns="0" tIns="0" rIns="0" bIns="0" anchor="t">
-            <a:spAutoFit/>
-          </a:bodyPr>
-          <a:lstStyle/>
-          <a:p>
-            <a:pPr algn="l">
-              <a:lnSpc>
-                <a:spcPct val="100000"/>
-              </a:lnSpc>
-            </a:pPr>
-            <a:r>
-              <a:rPr sz="1300" b="0" i="0">
-                <a:solidFill>
-                  <a:srgbClr val="777777"/>
-                </a:solidFill>
-                <a:latin typeface="Arial"/>
-              </a:rPr>
-              <a:t>Classification accuracy computed live from the AM decomposition run behind slide 7.</a:t>
-            </a:r>
-          </a:p>
-        </p:txBody>
-      </p:sp>
-    </p:spTree>
-  </p:cSld>
-  <p:clrMapOvr>
-    <a:masterClrMapping/>
-  </p:clrMapOvr>
-</p:sld>
-</file>
-
-<file path=ppt/slides/slide11.xml><?xml version="1.0" encoding="utf-8"?>
-<p:sld xmlns:a="http://schemas.openxmlformats.org/drawingml/2006/main" xmlns:r="http://schemas.openxmlformats.org/officeDocument/2006/relationships" xmlns:p="http://schemas.openxmlformats.org/presentationml/2006/main">
-  <p:cSld>
-    <p:bg>
-      <p:bgPr>
-        <a:solidFill>
           <a:srgbClr val="1F4E79"/>
         </a:solidFill>
         <a:effectLst/>
@@ -4553,7 +4132,7 @@
               </a:spcAft>
             </a:pPr>
             <a:r>
-              <a:rPr sz="2100" b="1">
+              <a:rPr sz="2100" b="1" dirty="0">
                 <a:solidFill>
                   <a:srgbClr val="FFFFFF"/>
                 </a:solidFill>
@@ -4562,7 +4141,7 @@
               <a:t>1. Dual-pane viewing and Gerber material assignment are done and verified: </a:t>
             </a:r>
             <a:r>
-              <a:rPr sz="2100" b="0">
+              <a:rPr sz="2100" b="0" dirty="0">
                 <a:solidFill>
                   <a:srgbClr val="FFFFFF"/>
                 </a:solidFill>
@@ -4581,7 +4160,7 @@
               </a:spcAft>
             </a:pPr>
             <a:r>
-              <a:rPr sz="2100" b="1">
+              <a:rPr sz="2100" b="1" dirty="0">
                 <a:solidFill>
                   <a:srgbClr val="FFFFFF"/>
                 </a:solidFill>
@@ -4590,7 +4169,7 @@
               <a:t>2. Registration and label transfer work end-to-end on synthetic ground truth: </a:t>
             </a:r>
             <a:r>
-              <a:rPr sz="2100" b="0">
+              <a:rPr sz="2100" b="0" dirty="0">
                 <a:solidFill>
                   <a:srgbClr val="FFFFFF"/>
                 </a:solidFill>
@@ -4609,16 +4188,52 @@
               </a:spcAft>
             </a:pPr>
             <a:r>
-              <a:rPr sz="2100" b="1">
+              <a:rPr sz="2100" b="1" dirty="0">
                 <a:solidFill>
                   <a:srgbClr val="FFFFFF"/>
                 </a:solidFill>
                 <a:latin typeface="Arial"/>
               </a:rPr>
-              <a:t>3. ρ_e (density) recovery is reliable; Z_eff (atomic number) recovery is noisy: </a:t>
-            </a:r>
-            <a:r>
-              <a:rPr sz="2100" b="0">
+              <a:t>3. </a:t>
+            </a:r>
+            <a:r>
+              <a:rPr sz="2100" b="1" dirty="0" err="1">
+                <a:solidFill>
+                  <a:srgbClr val="FFFFFF"/>
+                </a:solidFill>
+                <a:latin typeface="Arial"/>
+              </a:rPr>
+              <a:t>ρ_e</a:t>
+            </a:r>
+            <a:r>
+              <a:rPr sz="2100" b="1" dirty="0">
+                <a:solidFill>
+                  <a:srgbClr val="FFFFFF"/>
+                </a:solidFill>
+                <a:latin typeface="Arial"/>
+              </a:rPr>
+              <a:t> (density) recovery is reliable; </a:t>
+            </a:r>
+            <a:r>
+              <a:rPr sz="2100" b="1" dirty="0" err="1">
+                <a:solidFill>
+                  <a:srgbClr val="FFFFFF"/>
+                </a:solidFill>
+                <a:latin typeface="Arial"/>
+              </a:rPr>
+              <a:t>Z_eff</a:t>
+            </a:r>
+            <a:r>
+              <a:rPr sz="2100" b="1" dirty="0">
+                <a:solidFill>
+                  <a:srgbClr val="FFFFFF"/>
+                </a:solidFill>
+                <a:latin typeface="Arial"/>
+              </a:rPr>
+              <a:t> (atomic number) recovery is noisy: </a:t>
+            </a:r>
+            <a:r>
+              <a:rPr sz="2100" b="0" dirty="0">
                 <a:solidFill>
                   <a:srgbClr val="FFFFFF"/>
                 </a:solidFill>
@@ -4637,7 +4252,7 @@
               </a:spcAft>
             </a:pPr>
             <a:r>
-              <a:rPr sz="2100" b="1">
+              <a:rPr sz="2100" b="1" dirty="0">
                 <a:solidFill>
                   <a:srgbClr val="FFFFFF"/>
                 </a:solidFill>
@@ -4646,7 +4261,7 @@
               <a:t>4. The remaining gap is data, not method: </a:t>
             </a:r>
             <a:r>
-              <a:rPr sz="2100" b="0">
+              <a:rPr sz="2100" b="0" dirty="0">
                 <a:solidFill>
                   <a:srgbClr val="FFFFFF"/>
                 </a:solidFill>
@@ -6625,30 +6240,6 @@
           </a:p>
         </p:txBody>
       </p:sp>
-      <p:pic>
-        <p:nvPicPr>
-          <p:cNvPr id="5" name="Picture 4" descr="08_am_plot_zeff_rhoe.png"/>
-          <p:cNvPicPr>
-            <a:picLocks noChangeAspect="1"/>
-          </p:cNvPicPr>
-          <p:nvPr/>
-        </p:nvPicPr>
-        <p:blipFill>
-          <a:blip r:embed="rId2"/>
-          <a:stretch>
-            <a:fillRect/>
-          </a:stretch>
-        </p:blipFill>
-        <p:spPr>
-          <a:xfrm>
-            <a:off x="1508760" y="2112917"/>
-            <a:ext cx="5486400" cy="3135085"/>
-          </a:xfrm>
-          <a:prstGeom prst="rect">
-            <a:avLst/>
-          </a:prstGeom>
-        </p:spPr>
-      </p:pic>
       <p:sp>
         <p:nvSpPr>
           <p:cNvPr id="6" name="Rounded Rectangle 5"/>
@@ -6901,173 +6492,15 @@
           </a:p>
         </p:txBody>
       </p:sp>
-    </p:spTree>
-  </p:cSld>
-  <p:clrMapOvr>
-    <a:masterClrMapping/>
-  </p:clrMapOvr>
-</p:sld>
-</file>
-
-<file path=ppt/slides/slide8.xml><?xml version="1.0" encoding="utf-8"?>
-<p:sld xmlns:a="http://schemas.openxmlformats.org/drawingml/2006/main" xmlns:r="http://schemas.openxmlformats.org/officeDocument/2006/relationships" xmlns:p="http://schemas.openxmlformats.org/presentationml/2006/main">
-  <p:cSld>
-    <p:bg>
-      <p:bgPr>
-        <a:solidFill>
-          <a:srgbClr val="FFFFFF"/>
-        </a:solidFill>
-        <a:effectLst/>
-      </p:bgPr>
-    </p:bg>
-    <p:spTree>
-      <p:nvGrpSpPr>
-        <p:cNvPr id="1" name=""/>
-        <p:cNvGrpSpPr/>
-        <p:nvPr/>
-      </p:nvGrpSpPr>
-      <p:grpSpPr>
-        <a:xfrm>
-          <a:off x="0" y="0"/>
-          <a:ext cx="0" cy="0"/>
-          <a:chOff x="0" y="0"/>
-          <a:chExt cx="0" cy="0"/>
-        </a:xfrm>
-      </p:grpSpPr>
-      <p:sp>
-        <p:nvSpPr>
-          <p:cNvPr id="2" name="TextBox 1"/>
-          <p:cNvSpPr txBox="1"/>
-          <p:nvPr/>
-        </p:nvSpPr>
-        <p:spPr>
-          <a:xfrm>
-            <a:off x="457200" y="274320"/>
-            <a:ext cx="11277295" cy="868680"/>
-          </a:xfrm>
-          <a:prstGeom prst="rect">
-            <a:avLst/>
-          </a:prstGeom>
-          <a:noFill/>
-        </p:spPr>
-        <p:txBody>
-          <a:bodyPr wrap="square" lIns="0" tIns="0" rIns="0" bIns="0" anchor="t">
-            <a:spAutoFit/>
-          </a:bodyPr>
-          <a:lstStyle/>
-          <a:p>
-            <a:pPr algn="l">
-              <a:lnSpc>
-                <a:spcPct val="105000"/>
-              </a:lnSpc>
-            </a:pPr>
-            <a:r>
-              <a:rPr sz="2600" b="1" i="0">
-                <a:solidFill>
-                  <a:srgbClr val="1F4E79"/>
-                </a:solidFill>
-                <a:latin typeface="Arial"/>
-              </a:rPr>
-              <a:t>The registration tool recovers the known synthetic misalignment via 5 manually-set parameters</a:t>
-            </a:r>
-          </a:p>
-        </p:txBody>
-      </p:sp>
-      <p:sp>
-        <p:nvSpPr>
-          <p:cNvPr id="3" name="Rectangle 2"/>
-          <p:cNvSpPr/>
-          <p:nvPr/>
-        </p:nvSpPr>
-        <p:spPr>
-          <a:xfrm>
-            <a:off x="457200" y="1097280"/>
-            <a:ext cx="11277295" cy="19050"/>
-          </a:xfrm>
-          <a:prstGeom prst="rect">
-            <a:avLst/>
-          </a:prstGeom>
-          <a:solidFill>
-            <a:srgbClr val="CCCCCC"/>
-          </a:solidFill>
-          <a:ln>
-            <a:noFill/>
-          </a:ln>
-          <a:effectLst/>
-        </p:spPr>
-        <p:style>
-          <a:lnRef idx="1">
-            <a:schemeClr val="accent1"/>
-          </a:lnRef>
-          <a:fillRef idx="3">
-            <a:schemeClr val="accent1"/>
-          </a:fillRef>
-          <a:effectRef idx="2">
-            <a:schemeClr val="accent1"/>
-          </a:effectRef>
-          <a:fontRef idx="minor">
-            <a:schemeClr val="lt1"/>
-          </a:fontRef>
-        </p:style>
-        <p:txBody>
-          <a:bodyPr rtlCol="0" anchor="ctr"/>
-          <a:lstStyle/>
-          <a:p>
-            <a:pPr algn="ctr"/>
-            <a:endParaRPr/>
-          </a:p>
-        </p:txBody>
-      </p:sp>
-      <p:sp>
-        <p:nvSpPr>
-          <p:cNvPr id="4" name="Rectangle 3"/>
-          <p:cNvSpPr/>
-          <p:nvPr/>
-        </p:nvSpPr>
-        <p:spPr>
-          <a:xfrm>
-            <a:off x="457200" y="1234440"/>
-            <a:ext cx="6675120" cy="4892040"/>
-          </a:xfrm>
-          <a:prstGeom prst="rect">
-            <a:avLst/>
-          </a:prstGeom>
-          <a:solidFill>
-            <a:srgbClr val="F7F7F7"/>
-          </a:solidFill>
-          <a:ln w="12700">
-            <a:solidFill>
-              <a:srgbClr val="CCCCCC"/>
-            </a:solidFill>
-          </a:ln>
-          <a:effectLst/>
-        </p:spPr>
-        <p:style>
-          <a:lnRef idx="1">
-            <a:schemeClr val="accent1"/>
-          </a:lnRef>
-          <a:fillRef idx="3">
-            <a:schemeClr val="accent1"/>
-          </a:fillRef>
-          <a:effectRef idx="2">
-            <a:schemeClr val="accent1"/>
-          </a:effectRef>
-          <a:fontRef idx="minor">
-            <a:schemeClr val="lt1"/>
-          </a:fontRef>
-        </p:style>
-        <p:txBody>
-          <a:bodyPr rtlCol="0" anchor="ctr"/>
-          <a:lstStyle/>
-          <a:p>
-            <a:pPr algn="ctr"/>
-            <a:endParaRPr/>
-          </a:p>
-        </p:txBody>
-      </p:sp>
       <p:pic>
         <p:nvPicPr>
-          <p:cNvPr id="5" name="Picture 4" descr="03_controls.png"/>
+          <p:cNvPr id="12" name="Picture 11">
+            <a:extLst>
+              <a:ext uri="{FF2B5EF4-FFF2-40B4-BE49-F238E27FC236}">
+                <a16:creationId xmlns:a16="http://schemas.microsoft.com/office/drawing/2014/main" id="{D66CF519-3ADA-0ABF-2E31-9BC55728F3E5}"/>
+              </a:ext>
+            </a:extLst>
+          </p:cNvPr>
           <p:cNvPicPr>
             <a:picLocks noChangeAspect="1"/>
           </p:cNvPicPr>
@@ -7081,251 +6514,14 @@
         </p:blipFill>
         <p:spPr>
           <a:xfrm>
-            <a:off x="502920" y="2627071"/>
-            <a:ext cx="6583680" cy="2106777"/>
+            <a:off x="1463040" y="2141220"/>
+            <a:ext cx="5522499" cy="3482340"/>
           </a:xfrm>
           <a:prstGeom prst="rect">
             <a:avLst/>
           </a:prstGeom>
         </p:spPr>
       </p:pic>
-      <p:grpSp>
-        <p:nvGrpSpPr>
-          <p:cNvPr id="11" name="Group 10">
-            <a:extLst>
-              <a:ext uri="{FF2B5EF4-FFF2-40B4-BE49-F238E27FC236}">
-                <a16:creationId xmlns:a16="http://schemas.microsoft.com/office/drawing/2014/main" id="{D22D7560-EA1D-CB96-989F-656416EF577A}"/>
-              </a:ext>
-            </a:extLst>
-          </p:cNvPr>
-          <p:cNvGrpSpPr/>
-          <p:nvPr/>
-        </p:nvGrpSpPr>
-        <p:grpSpPr>
-          <a:xfrm>
-            <a:off x="2606040" y="1679296"/>
-            <a:ext cx="2377440" cy="502920"/>
-            <a:chOff x="8412480" y="5349240"/>
-            <a:chExt cx="2377440" cy="502920"/>
-          </a:xfrm>
-        </p:grpSpPr>
-        <p:sp>
-          <p:nvSpPr>
-            <p:cNvPr id="6" name="Rounded Rectangle 5"/>
-            <p:cNvSpPr/>
-            <p:nvPr/>
-          </p:nvSpPr>
-          <p:spPr>
-            <a:xfrm>
-              <a:off x="8412480" y="5349240"/>
-              <a:ext cx="2377440" cy="502920"/>
-            </a:xfrm>
-            <a:prstGeom prst="roundRect">
-              <a:avLst>
-                <a:gd name="adj" fmla="val 15000"/>
-              </a:avLst>
-            </a:prstGeom>
-            <a:solidFill>
-              <a:srgbClr val="FFF2CC"/>
-            </a:solidFill>
-            <a:ln w="12700">
-              <a:solidFill>
-                <a:srgbClr val="E6C800"/>
-              </a:solidFill>
-            </a:ln>
-            <a:effectLst/>
-          </p:spPr>
-          <p:style>
-            <a:lnRef idx="1">
-              <a:schemeClr val="accent1"/>
-            </a:lnRef>
-            <a:fillRef idx="3">
-              <a:schemeClr val="accent1"/>
-            </a:fillRef>
-            <a:effectRef idx="2">
-              <a:schemeClr val="accent1"/>
-            </a:effectRef>
-            <a:fontRef idx="minor">
-              <a:schemeClr val="lt1"/>
-            </a:fontRef>
-          </p:style>
-          <p:txBody>
-            <a:bodyPr rtlCol="0" anchor="ctr"/>
-            <a:lstStyle/>
-            <a:p>
-              <a:pPr algn="ctr"/>
-              <a:endParaRPr/>
-            </a:p>
-          </p:txBody>
-        </p:sp>
-        <p:sp>
-          <p:nvSpPr>
-            <p:cNvPr id="7" name="TextBox 6"/>
-            <p:cNvSpPr txBox="1"/>
-            <p:nvPr/>
-          </p:nvSpPr>
-          <p:spPr>
-            <a:xfrm>
-              <a:off x="8412480" y="5349240"/>
-              <a:ext cx="2377440" cy="502920"/>
-            </a:xfrm>
-            <a:prstGeom prst="rect">
-              <a:avLst/>
-            </a:prstGeom>
-            <a:noFill/>
-          </p:spPr>
-          <p:txBody>
-            <a:bodyPr wrap="square" lIns="0" tIns="0" rIns="0" bIns="0" anchor="ctr">
-              <a:spAutoFit/>
-            </a:bodyPr>
-            <a:lstStyle/>
-            <a:p>
-              <a:pPr algn="ctr">
-                <a:lnSpc>
-                  <a:spcPct val="100000"/>
-                </a:lnSpc>
-              </a:pPr>
-              <a:r>
-                <a:rPr sz="1600" b="1" i="0" dirty="0">
-                  <a:solidFill>
-                    <a:srgbClr val="7A5200"/>
-                  </a:solidFill>
-                  <a:latin typeface="Arial"/>
-                </a:rPr>
-                <a:t>Real accepted values</a:t>
-              </a:r>
-            </a:p>
-          </p:txBody>
-        </p:sp>
-      </p:grpSp>
-      <p:sp>
-        <p:nvSpPr>
-          <p:cNvPr id="8" name="TextBox 7"/>
-          <p:cNvSpPr txBox="1"/>
-          <p:nvPr/>
-        </p:nvSpPr>
-        <p:spPr>
-          <a:xfrm>
-            <a:off x="7452360" y="1234440"/>
-            <a:ext cx="4297680" cy="365760"/>
-          </a:xfrm>
-          <a:prstGeom prst="rect">
-            <a:avLst/>
-          </a:prstGeom>
-          <a:noFill/>
-        </p:spPr>
-        <p:txBody>
-          <a:bodyPr wrap="square" lIns="0" tIns="0" rIns="0" bIns="0" anchor="t">
-            <a:spAutoFit/>
-          </a:bodyPr>
-          <a:lstStyle/>
-          <a:p>
-            <a:pPr algn="l">
-              <a:lnSpc>
-                <a:spcPct val="100000"/>
-              </a:lnSpc>
-            </a:pPr>
-            <a:r>
-              <a:rPr sz="2200" b="1" i="0">
-                <a:solidFill>
-                  <a:srgbClr val="2E75B6"/>
-                </a:solidFill>
-                <a:latin typeface="Arial"/>
-              </a:rPr>
-              <a:t>What to take away</a:t>
-            </a:r>
-          </a:p>
-        </p:txBody>
-      </p:sp>
-      <p:sp>
-        <p:nvSpPr>
-          <p:cNvPr id="9" name="TextBox 8"/>
-          <p:cNvSpPr txBox="1"/>
-          <p:nvPr/>
-        </p:nvSpPr>
-        <p:spPr>
-          <a:xfrm>
-            <a:off x="7452360" y="1691640"/>
-            <a:ext cx="4297680" cy="3931920"/>
-          </a:xfrm>
-          <a:prstGeom prst="rect">
-            <a:avLst/>
-          </a:prstGeom>
-          <a:noFill/>
-        </p:spPr>
-        <p:txBody>
-          <a:bodyPr wrap="square">
-            <a:spAutoFit/>
-          </a:bodyPr>
-          <a:lstStyle/>
-          <a:p>
-            <a:pPr>
-              <a:lnSpc>
-                <a:spcPct val="105000"/>
-              </a:lnSpc>
-              <a:spcAft>
-                <a:spcPts val="1200"/>
-              </a:spcAft>
-            </a:pPr>
-            <a:r>
-              <a:rPr sz="1900">
-                <a:solidFill>
-                  <a:srgbClr val="2D2D2D"/>
-                </a:solidFill>
-                <a:latin typeface="Arial"/>
-              </a:rPr>
-              <a:t>•  Live red/green overlay preview updates as each parameter changes (debounced for large volumes).</a:t>
-            </a:r>
-          </a:p>
-          <a:p>
-            <a:pPr>
-              <a:lnSpc>
-                <a:spcPct val="105000"/>
-              </a:lnSpc>
-              <a:spcAft>
-                <a:spcPts val="1200"/>
-              </a:spcAft>
-            </a:pPr>
-            <a:r>
-              <a:rPr sz="1900" b="1">
-                <a:solidFill>
-                  <a:srgbClr val="2D2D2D"/>
-                </a:solidFill>
-                <a:latin typeface="Arial"/>
-              </a:rPr>
-              <a:t>•  Accepted transform: </a:t>
-            </a:r>
-            <a:r>
-              <a:rPr sz="1900" b="0">
-                <a:solidFill>
-                  <a:srgbClr val="2D2D2D"/>
-                </a:solidFill>
-                <a:latin typeface="Arial"/>
-              </a:rPr>
-              <a:t>Tx=0.20mm, Ty=−0.15mm, Tz=0.02mm, Rot Z=3.00°, Scale=1.02×.</a:t>
-            </a:r>
-          </a:p>
-          <a:p>
-            <a:pPr>
-              <a:lnSpc>
-                <a:spcPct val="105000"/>
-              </a:lnSpc>
-              <a:spcAft>
-                <a:spcPts val="1200"/>
-              </a:spcAft>
-            </a:pPr>
-            <a:r>
-              <a:rPr sz="1900">
-                <a:solidFill>
-                  <a:srgbClr val="2D2D2D"/>
-                </a:solidFill>
-                <a:latin typeface="Arial"/>
-              </a:rPr>
-              <a:t>•  Matches the known misalignment built into the synthetic test fixture.</a:t>
-            </a:r>
-          </a:p>
-        </p:txBody>
-      </p:sp>
     </p:spTree>
   </p:cSld>
   <p:clrMapOvr>
@@ -7334,7 +6530,7 @@
 </p:sld>
 </file>
 
-<file path=ppt/slides/slide9.xml><?xml version="1.0" encoding="utf-8"?>
+<file path=ppt/slides/slide8.xml><?xml version="1.0" encoding="utf-8"?>
 <p:sld xmlns:a="http://schemas.openxmlformats.org/drawingml/2006/main" xmlns:r="http://schemas.openxmlformats.org/officeDocument/2006/relationships" xmlns:p="http://schemas.openxmlformats.org/presentationml/2006/main">
   <p:cSld>
     <p:bg>
@@ -7671,7 +6867,7 @@
         <p:spPr>
           <a:xfrm>
             <a:off x="7452360" y="1691640"/>
-            <a:ext cx="4297680" cy="3931920"/>
+            <a:ext cx="4297680" cy="3141886"/>
           </a:xfrm>
           <a:prstGeom prst="rect">
             <a:avLst/>
@@ -7693,7 +6889,7 @@
               </a:spcAft>
             </a:pPr>
             <a:r>
-              <a:rPr sz="1900" b="1">
+              <a:rPr sz="1900" b="1" dirty="0">
                 <a:solidFill>
                   <a:srgbClr val="2D2D2D"/>
                 </a:solidFill>
@@ -7702,7 +6898,7 @@
               <a:t>•  Left: </a:t>
             </a:r>
             <a:r>
-              <a:rPr sz="1900" b="0">
+              <a:rPr sz="1900" b="0" dirty="0">
                 <a:solidFill>
                   <a:srgbClr val="2D2D2D"/>
                 </a:solidFill>
@@ -7721,7 +6917,7 @@
               </a:spcAft>
             </a:pPr>
             <a:r>
-              <a:rPr sz="1900" b="1">
+              <a:rPr sz="1900" b="1" dirty="0">
                 <a:solidFill>
                   <a:srgbClr val="2D2D2D"/>
                 </a:solidFill>
@@ -7730,7 +6926,7 @@
               <a:t>•  Right: </a:t>
             </a:r>
             <a:r>
-              <a:rPr sz="1900" b="0">
+              <a:rPr sz="1900" b="0" dirty="0">
                 <a:solidFill>
                   <a:srgbClr val="2D2D2D"/>
                 </a:solidFill>
@@ -7749,13 +6945,460 @@
               </a:spcAft>
             </a:pPr>
             <a:r>
+              <a:rPr sz="1900" dirty="0">
+                <a:solidFill>
+                  <a:srgbClr val="2D2D2D"/>
+                </a:solidFill>
+                <a:latin typeface="Arial"/>
+              </a:rPr>
+              <a:t>•  Nearest-neighbor </a:t>
+            </a:r>
+            <a:r>
+              <a:rPr lang="en-US" sz="1900" dirty="0" err="1">
+                <a:solidFill>
+                  <a:srgbClr val="2D2D2D"/>
+                </a:solidFill>
+                <a:latin typeface="Arial"/>
+              </a:rPr>
+              <a:t>cros</a:t>
+            </a:r>
+            <a:r>
+              <a:rPr sz="1900" dirty="0" err="1">
+                <a:solidFill>
+                  <a:srgbClr val="2D2D2D"/>
+                </a:solidFill>
+                <a:latin typeface="Arial"/>
+              </a:rPr>
+              <a:t>resampling</a:t>
+            </a:r>
+            <a:r>
+              <a:rPr sz="1900" dirty="0">
+                <a:solidFill>
+                  <a:srgbClr val="2D2D2D"/>
+                </a:solidFill>
+                <a:latin typeface="Arial"/>
+              </a:rPr>
+              <a:t> guarantees only real material IDs appear in the output—no interpolated "in-between" materials.</a:t>
+            </a:r>
+          </a:p>
+        </p:txBody>
+      </p:sp>
+    </p:spTree>
+  </p:cSld>
+  <p:clrMapOvr>
+    <a:masterClrMapping/>
+  </p:clrMapOvr>
+</p:sld>
+</file>
+
+<file path=ppt/slides/slide9.xml><?xml version="1.0" encoding="utf-8"?>
+<p:sld xmlns:a="http://schemas.openxmlformats.org/drawingml/2006/main" xmlns:r="http://schemas.openxmlformats.org/officeDocument/2006/relationships" xmlns:p="http://schemas.openxmlformats.org/presentationml/2006/main">
+  <p:cSld>
+    <p:bg>
+      <p:bgPr>
+        <a:solidFill>
+          <a:srgbClr val="FFFFFF"/>
+        </a:solidFill>
+        <a:effectLst/>
+      </p:bgPr>
+    </p:bg>
+    <p:spTree>
+      <p:nvGrpSpPr>
+        <p:cNvPr id="1" name=""/>
+        <p:cNvGrpSpPr/>
+        <p:nvPr/>
+      </p:nvGrpSpPr>
+      <p:grpSpPr>
+        <a:xfrm>
+          <a:off x="0" y="0"/>
+          <a:ext cx="0" cy="0"/>
+          <a:chOff x="0" y="0"/>
+          <a:chExt cx="0" cy="0"/>
+        </a:xfrm>
+      </p:grpSpPr>
+      <p:sp>
+        <p:nvSpPr>
+          <p:cNvPr id="2" name="TextBox 1"/>
+          <p:cNvSpPr txBox="1"/>
+          <p:nvPr/>
+        </p:nvSpPr>
+        <p:spPr>
+          <a:xfrm>
+            <a:off x="457200" y="274320"/>
+            <a:ext cx="11277295" cy="868680"/>
+          </a:xfrm>
+          <a:prstGeom prst="rect">
+            <a:avLst/>
+          </a:prstGeom>
+          <a:noFill/>
+        </p:spPr>
+        <p:txBody>
+          <a:bodyPr wrap="square" lIns="0" tIns="0" rIns="0" bIns="0" anchor="t">
+            <a:spAutoFit/>
+          </a:bodyPr>
+          <a:lstStyle/>
+          <a:p>
+            <a:pPr algn="l">
+              <a:lnSpc>
+                <a:spcPct val="105000"/>
+              </a:lnSpc>
+            </a:pPr>
+            <a:r>
+              <a:rPr sz="2600" b="1" i="0">
+                <a:solidFill>
+                  <a:srgbClr val="1F4E79"/>
+                </a:solidFill>
+                <a:latin typeface="Arial"/>
+              </a:rPr>
+              <a:t>Z_eff noise limits classification accuracy, and no real matched dataset exists yet to validate end-to-end</a:t>
+            </a:r>
+          </a:p>
+        </p:txBody>
+      </p:sp>
+      <p:sp>
+        <p:nvSpPr>
+          <p:cNvPr id="3" name="Rectangle 2"/>
+          <p:cNvSpPr/>
+          <p:nvPr/>
+        </p:nvSpPr>
+        <p:spPr>
+          <a:xfrm>
+            <a:off x="457200" y="1097280"/>
+            <a:ext cx="11277295" cy="19050"/>
+          </a:xfrm>
+          <a:prstGeom prst="rect">
+            <a:avLst/>
+          </a:prstGeom>
+          <a:solidFill>
+            <a:srgbClr val="CCCCCC"/>
+          </a:solidFill>
+          <a:ln>
+            <a:noFill/>
+          </a:ln>
+          <a:effectLst/>
+        </p:spPr>
+        <p:style>
+          <a:lnRef idx="1">
+            <a:schemeClr val="accent1"/>
+          </a:lnRef>
+          <a:fillRef idx="3">
+            <a:schemeClr val="accent1"/>
+          </a:fillRef>
+          <a:effectRef idx="2">
+            <a:schemeClr val="accent1"/>
+          </a:effectRef>
+          <a:fontRef idx="minor">
+            <a:schemeClr val="lt1"/>
+          </a:fontRef>
+        </p:style>
+        <p:txBody>
+          <a:bodyPr rtlCol="0" anchor="ctr"/>
+          <a:lstStyle/>
+          <a:p>
+            <a:pPr algn="ctr"/>
+            <a:endParaRPr/>
+          </a:p>
+        </p:txBody>
+      </p:sp>
+      <p:sp>
+        <p:nvSpPr>
+          <p:cNvPr id="4" name="TextBox 3"/>
+          <p:cNvSpPr txBox="1"/>
+          <p:nvPr/>
+        </p:nvSpPr>
+        <p:spPr>
+          <a:xfrm>
+            <a:off x="457200" y="1234440"/>
+            <a:ext cx="5486400" cy="365760"/>
+          </a:xfrm>
+          <a:prstGeom prst="rect">
+            <a:avLst/>
+          </a:prstGeom>
+          <a:noFill/>
+        </p:spPr>
+        <p:txBody>
+          <a:bodyPr wrap="square" lIns="0" tIns="0" rIns="0" bIns="0" anchor="t">
+            <a:spAutoFit/>
+          </a:bodyPr>
+          <a:lstStyle/>
+          <a:p>
+            <a:pPr algn="l">
+              <a:lnSpc>
+                <a:spcPct val="100000"/>
+              </a:lnSpc>
+            </a:pPr>
+            <a:r>
+              <a:rPr sz="2200" b="1" i="0">
+                <a:solidFill>
+                  <a:srgbClr val="2E75B6"/>
+                </a:solidFill>
+                <a:latin typeface="Arial"/>
+              </a:rPr>
+              <a:t>Interpretation</a:t>
+            </a:r>
+          </a:p>
+        </p:txBody>
+      </p:sp>
+      <p:sp>
+        <p:nvSpPr>
+          <p:cNvPr id="5" name="TextBox 4"/>
+          <p:cNvSpPr txBox="1"/>
+          <p:nvPr/>
+        </p:nvSpPr>
+        <p:spPr>
+          <a:xfrm>
+            <a:off x="457200" y="1645920"/>
+            <a:ext cx="5486400" cy="2011680"/>
+          </a:xfrm>
+          <a:prstGeom prst="rect">
+            <a:avLst/>
+          </a:prstGeom>
+          <a:noFill/>
+        </p:spPr>
+        <p:txBody>
+          <a:bodyPr wrap="square">
+            <a:spAutoFit/>
+          </a:bodyPr>
+          <a:lstStyle/>
+          <a:p>
+            <a:pPr>
+              <a:lnSpc>
+                <a:spcPct val="105000"/>
+              </a:lnSpc>
+              <a:spcAft>
+                <a:spcPts val="1200"/>
+              </a:spcAft>
+            </a:pPr>
+            <a:r>
               <a:rPr sz="1900">
                 <a:solidFill>
                   <a:srgbClr val="2D2D2D"/>
                 </a:solidFill>
                 <a:latin typeface="Arial"/>
               </a:rPr>
-              <a:t>•  Nearest-neighbor (not trilinear) resampling guarantees only real material IDs appear in the output—no interpolated "in-between" materials.</a:t>
+              <a:t>•  Ground-truth classification: 100% correct (exact input, sanity check).</a:t>
+            </a:r>
+          </a:p>
+          <a:p>
+            <a:pPr>
+              <a:lnSpc>
+                <a:spcPct val="105000"/>
+              </a:lnSpc>
+              <a:spcAft>
+                <a:spcPts val="1200"/>
+              </a:spcAft>
+            </a:pPr>
+            <a:r>
+              <a:rPr sz="1900">
+                <a:solidFill>
+                  <a:srgbClr val="2D2D2D"/>
+                </a:solidFill>
+                <a:latin typeface="Arial"/>
+              </a:rPr>
+              <a:t>•  Recovered/noisy classification: 56% voxel agreement against ground truth.</a:t>
+            </a:r>
+          </a:p>
+          <a:p>
+            <a:pPr>
+              <a:lnSpc>
+                <a:spcPct val="105000"/>
+              </a:lnSpc>
+              <a:spcAft>
+                <a:spcPts val="1200"/>
+              </a:spcAft>
+            </a:pPr>
+            <a:r>
+              <a:rPr sz="1900" b="1">
+                <a:solidFill>
+                  <a:srgbClr val="2D2D2D"/>
+                </a:solidFill>
+                <a:latin typeface="Arial"/>
+              </a:rPr>
+              <a:t>•  Cause: </a:t>
+            </a:r>
+            <a:r>
+              <a:rPr sz="1900" b="0">
+                <a:solidFill>
+                  <a:srgbClr val="2D2D2D"/>
+                </a:solidFill>
+                <a:latin typeface="Arial"/>
+              </a:rPr>
+              <a:t>Z_eff's ratio-based recovery is inherently noisier than ρ_e, especially for low-Z materials like FR4.</a:t>
+            </a:r>
+          </a:p>
+        </p:txBody>
+      </p:sp>
+      <p:graphicFrame>
+        <p:nvGraphicFramePr>
+          <p:cNvPr id="6" name="Chart 5"/>
+          <p:cNvGraphicFramePr>
+            <a:graphicFrameLocks noGrp="1"/>
+          </p:cNvGraphicFramePr>
+          <p:nvPr/>
+        </p:nvGraphicFramePr>
+        <p:xfrm>
+          <a:off x="6309360" y="1371600"/>
+          <a:ext cx="5029200" cy="3108960"/>
+        </p:xfrm>
+        <a:graphic>
+          <a:graphicData uri="http://schemas.openxmlformats.org/drawingml/2006/chart">
+            <c:chart xmlns:c="http://schemas.openxmlformats.org/drawingml/2006/chart" xmlns:r="http://schemas.openxmlformats.org/officeDocument/2006/relationships" r:id="rId2"/>
+          </a:graphicData>
+        </a:graphic>
+      </p:graphicFrame>
+      <p:sp>
+        <p:nvSpPr>
+          <p:cNvPr id="7" name="TextBox 6"/>
+          <p:cNvSpPr txBox="1"/>
+          <p:nvPr/>
+        </p:nvSpPr>
+        <p:spPr>
+          <a:xfrm>
+            <a:off x="457200" y="4434840"/>
+            <a:ext cx="5486400" cy="365760"/>
+          </a:xfrm>
+          <a:prstGeom prst="rect">
+            <a:avLst/>
+          </a:prstGeom>
+          <a:noFill/>
+        </p:spPr>
+        <p:txBody>
+          <a:bodyPr wrap="square" lIns="0" tIns="0" rIns="0" bIns="0" anchor="t">
+            <a:spAutoFit/>
+          </a:bodyPr>
+          <a:lstStyle/>
+          <a:p>
+            <a:pPr algn="l">
+              <a:lnSpc>
+                <a:spcPct val="100000"/>
+              </a:lnSpc>
+            </a:pPr>
+            <a:r>
+              <a:rPr sz="2200" b="1" i="0">
+                <a:solidFill>
+                  <a:srgbClr val="2E75B6"/>
+                </a:solidFill>
+                <a:latin typeface="Arial"/>
+              </a:rPr>
+              <a:t>Main limitation</a:t>
+            </a:r>
+          </a:p>
+        </p:txBody>
+      </p:sp>
+      <p:sp>
+        <p:nvSpPr>
+          <p:cNvPr id="8" name="TextBox 7"/>
+          <p:cNvSpPr txBox="1"/>
+          <p:nvPr/>
+        </p:nvSpPr>
+        <p:spPr>
+          <a:xfrm>
+            <a:off x="457200" y="4846320"/>
+            <a:ext cx="11277295" cy="1463040"/>
+          </a:xfrm>
+          <a:prstGeom prst="rect">
+            <a:avLst/>
+          </a:prstGeom>
+          <a:noFill/>
+        </p:spPr>
+        <p:txBody>
+          <a:bodyPr wrap="square">
+            <a:spAutoFit/>
+          </a:bodyPr>
+          <a:lstStyle/>
+          <a:p>
+            <a:pPr>
+              <a:lnSpc>
+                <a:spcPct val="105000"/>
+              </a:lnSpc>
+              <a:spcAft>
+                <a:spcPts val="1200"/>
+              </a:spcAft>
+            </a:pPr>
+            <a:r>
+              <a:rPr sz="1900" b="1">
+                <a:solidFill>
+                  <a:srgbClr val="2D2D2D"/>
+                </a:solidFill>
+                <a:latin typeface="Arial"/>
+              </a:rPr>
+              <a:t>•  External validity: </a:t>
+            </a:r>
+            <a:r>
+              <a:rPr sz="1900" b="0">
+                <a:solidFill>
+                  <a:srgbClr val="2D2D2D"/>
+                </a:solidFill>
+                <a:latin typeface="Arial"/>
+              </a:rPr>
+              <a:t>the only real CT sample in the repo is a battery scan, not a PCB—end-to-end registration is validated only on synthetic data so far.</a:t>
+            </a:r>
+          </a:p>
+          <a:p>
+            <a:pPr>
+              <a:lnSpc>
+                <a:spcPct val="105000"/>
+              </a:lnSpc>
+              <a:spcAft>
+                <a:spcPts val="1200"/>
+              </a:spcAft>
+            </a:pPr>
+            <a:r>
+              <a:rPr sz="1900" b="1">
+                <a:solidFill>
+                  <a:srgbClr val="2D2D2D"/>
+                </a:solidFill>
+                <a:latin typeface="Arial"/>
+              </a:rPr>
+              <a:t>•  Next validation step: </a:t>
+            </a:r>
+            <a:r>
+              <a:rPr sz="1900" b="0">
+                <a:solidFill>
+                  <a:srgbClr val="2D2D2D"/>
+                </a:solidFill>
+                <a:latin typeface="Arial"/>
+              </a:rPr>
+              <a:t>acquire or locate a real CT scan with a matching known Gerber design.</a:t>
+            </a:r>
+          </a:p>
+        </p:txBody>
+      </p:sp>
+      <p:sp>
+        <p:nvSpPr>
+          <p:cNvPr id="9" name="TextBox 8"/>
+          <p:cNvSpPr txBox="1"/>
+          <p:nvPr/>
+        </p:nvSpPr>
+        <p:spPr>
+          <a:xfrm>
+            <a:off x="457200" y="6446520"/>
+            <a:ext cx="11277295" cy="320040"/>
+          </a:xfrm>
+          <a:prstGeom prst="rect">
+            <a:avLst/>
+          </a:prstGeom>
+          <a:noFill/>
+        </p:spPr>
+        <p:txBody>
+          <a:bodyPr wrap="square" lIns="0" tIns="0" rIns="0" bIns="0" anchor="t">
+            <a:spAutoFit/>
+          </a:bodyPr>
+          <a:lstStyle/>
+          <a:p>
+            <a:pPr algn="l">
+              <a:lnSpc>
+                <a:spcPct val="100000"/>
+              </a:lnSpc>
+            </a:pPr>
+            <a:r>
+              <a:rPr sz="1300" b="0" i="0">
+                <a:solidFill>
+                  <a:srgbClr val="777777"/>
+                </a:solidFill>
+                <a:latin typeface="Arial"/>
+              </a:rPr>
+              <a:t>Classification accuracy computed live from the AM decomposition run behind slide 7.</a:t>
             </a:r>
           </a:p>
         </p:txBody>

</xml_diff>